<commit_message>
docs(intermodular): enfocar propuesta de Tarea 0 e Hito 1 en venta de servicio para tiendas locales
</commit_message>
<xml_diff>
--- a/Proyecto intermodular/UD1/Tarea0-2DAM/Tarea0_LeadCraft_Presentacion.pptx
+++ b/Proyecto intermodular/UD1/Tarea0-2DAM/Tarea0_LeadCraft_Presentacion.pptx
@@ -3299,7 +3299,7 @@
               </a:defRPr>
             </a:pPr>
             <a:r>
-              <a:t>¿Qué ocurre con la digitalización de los pequeños comercios locales?</a:t>
+              <a:t>¿Por qué los comercios locales tienen dificultades para llevar su negocio en Internet?</a:t>
             </a:r>
           </a:p>
         </p:txBody>
@@ -3370,7 +3370,7 @@
               </a:defRPr>
             </a:pPr>
             <a:r>
-              <a:t>• Desconexión Digital en el Barrio:</a:t>
+              <a:t>• Sobrecarga en la Tienda Física:</a:t>
             </a:r>
           </a:p>
           <a:p>
@@ -3386,7 +3386,7 @@
               </a:defRPr>
             </a:pPr>
             <a:r>
-              <a:t>   Miles de negocios locales solo tienen ficha en Google Maps pero carecen de web propia o citas online.</a:t>
+              <a:t>   Los comerciantes atienden a clientes en local y carecen de tiempo para llevar citas, web y catálogo online.</a:t>
             </a:r>
           </a:p>
           <a:p>
@@ -3399,7 +3399,7 @@
               </a:defRPr>
             </a:pPr>
             <a:r>
-              <a:t>• Barreras de Coste y Tiempo:</a:t>
+              <a:t>• Costes Inasumibles de Agencias:</a:t>
             </a:r>
           </a:p>
           <a:p>
@@ -3415,7 +3415,7 @@
               </a:defRPr>
             </a:pPr>
             <a:r>
-              <a:t>   Las agencias tradicionales cobran entre 800€ y 2.500€, un coste inasumible para pequeños comercios.</a:t>
+              <a:t>   Las agencias tradicionales cobran más de 1.000€ más cuotas altas, algo inviable para un negocio de barrio.</a:t>
             </a:r>
           </a:p>
           <a:p>
@@ -3428,7 +3428,7 @@
               </a:defRPr>
             </a:pPr>
             <a:r>
-              <a:t>• Prospección Lenta e Ineficiente:</a:t>
+              <a:t>• Pérdida Continua de Clientes:</a:t>
             </a:r>
           </a:p>
           <a:p>
@@ -3444,7 +3444,7 @@
               </a:defRPr>
             </a:pPr>
             <a:r>
-              <a:t>   Los comerciales pierden semanas contactando en frío sin una propuesta visual que convenza al dueño.</a:t>
+              <a:t>   Sin reservas online ni presencia digital cuidada, pierden ventas a diario frente a grandes franquicias.</a:t>
             </a:r>
           </a:p>
         </p:txBody>
@@ -3515,7 +3515,7 @@
               </a:defRPr>
             </a:pPr>
             <a:r>
-              <a:t>• Pymes y Comercios Locales:</a:t>
+              <a:t>• Dueños de Tiendas y Comercios Locales:</a:t>
             </a:r>
           </a:p>
           <a:p>
@@ -3531,7 +3531,7 @@
               </a:defRPr>
             </a:pPr>
             <a:r>
-              <a:t>   Peluquerías, talleres, clínicas y bares que pierden clientes frente a franquicias por no tener reservas.</a:t>
+              <a:t>   Peluquerías, talleres, clínicas y bares que necesitan digitalizarse sin complicaciones técnicas.</a:t>
             </a:r>
           </a:p>
           <a:p>
@@ -3544,7 +3544,7 @@
               </a:defRPr>
             </a:pPr>
             <a:r>
-              <a:t>• Freelancers y Jóvenes Desarrolladores:</a:t>
+              <a:t>• Clientes y Vecinos del Barrio:</a:t>
             </a:r>
           </a:p>
           <a:p>
@@ -3560,7 +3560,7 @@
               </a:defRPr>
             </a:pPr>
             <a:r>
-              <a:t>   Buscan captar clientes de proximidad pero carecen de herramientas para auditar y generar demos rápidas.</a:t>
+              <a:t>   Buscan pedir cita, consultar precios y contactar desde el móvil 24/7 sin llamadas en horario comercial.</a:t>
             </a:r>
           </a:p>
           <a:p>
@@ -3573,7 +3573,7 @@
               </a:defRPr>
             </a:pPr>
             <a:r>
-              <a:t>• Economía Local y ODS 8:</a:t>
+              <a:t>• Titulados de DAM y Freelancers:</a:t>
             </a:r>
           </a:p>
           <a:p>
@@ -3589,7 +3589,7 @@
               </a:defRPr>
             </a:pPr>
             <a:r>
-              <a:t>   El comercio tradicional pierde competitividad. Resolverlo impulsa el ODS 8 y el ODS 9 (innovación accesible).</a:t>
+              <a:t>   Oportunidad de ofrecer y vender un servicio recurrente de gestión digital 'llave en mano' en su entorno.</a:t>
             </a:r>
           </a:p>
         </p:txBody>
@@ -3863,7 +3863,7 @@
               </a:defRPr>
             </a:pPr>
             <a:r>
-              <a:t>2. LeadCraft AI: Propuesta Digital y Funcionalidades</a:t>
+              <a:t>2. LeadCraft AI: Venta del Servicio Digital para Tiendas</a:t>
             </a:r>
           </a:p>
           <a:p>
@@ -3876,7 +3876,7 @@
               </a:defRPr>
             </a:pPr>
             <a:r>
-              <a:t>Plataforma de prospección sobre Google Maps con auditoría y generador web con IA</a:t>
+              <a:t>Servicio 'todo en uno' para poner en marcha y llevar el negocio del comerciante en Internet</a:t>
             </a:r>
           </a:p>
         </p:txBody>
@@ -3958,7 +3958,7 @@
               </a:defRPr>
             </a:pPr>
             <a:r>
-              <a:t>⚡ FUNCIONALIDADES CLAVE</a:t>
+              <a:t>⚡ FUNCIONALIDADES CLAVE DEL SERVICIO</a:t>
             </a:r>
           </a:p>
           <a:p>
@@ -3971,7 +3971,7 @@
               </a:defRPr>
             </a:pPr>
             <a:r>
-              <a:t>🗺️ Explorador Geográfico en Google Maps</a:t>
+              <a:t>🗺️ Prospección y Auditoría en Google Maps</a:t>
             </a:r>
           </a:p>
           <a:p>
@@ -3987,7 +3987,7 @@
               </a:defRPr>
             </a:pPr>
             <a:r>
-              <a:t>Localiza comercios por zona y sector (ej. peluquerías en Chamberí).</a:t>
+              <a:t>Localiza comercios y detecta carencias digitales (sin web, sin reservas).</a:t>
             </a:r>
           </a:p>
           <a:p>
@@ -4000,7 +4000,7 @@
               </a:defRPr>
             </a:pPr>
             <a:r>
-              <a:t>🔍 Auditoría Digital Express en 3s</a:t>
+              <a:t>🤖 Web Asistida por IA para el Negocio</a:t>
             </a:r>
           </a:p>
           <a:p>
@@ -4016,7 +4016,7 @@
               </a:defRPr>
             </a:pPr>
             <a:r>
-              <a:t>Detecta si el local tiene web, SSL, reservas, redes y analiza reseñas.</a:t>
+              <a:t>Genera la web con horarios, catálogo y fotos extraídas de la ficha.</a:t>
             </a:r>
           </a:p>
           <a:p>
@@ -4029,7 +4029,7 @@
               </a:defRPr>
             </a:pPr>
             <a:r>
-              <a:t>🤖 Generador de Landing Pages con IA</a:t>
+              <a:t>📅 Sistema Integrado de Citas Online 24/7</a:t>
             </a:r>
           </a:p>
           <a:p>
@@ -4045,7 +4045,7 @@
               </a:defRPr>
             </a:pPr>
             <a:r>
-              <a:t>Redacta contenido y monta la web usando datos de Maps (horarios, fotos).</a:t>
+              <a:t>Calendario interactivo con franjas horarias y confirmación inmediata.</a:t>
             </a:r>
           </a:p>
           <a:p>
@@ -4058,7 +4058,7 @@
               </a:defRPr>
             </a:pPr>
             <a:r>
-              <a:t>📅 Widget Integrado de Citas Online</a:t>
+              <a:t>💬 Canal de Contacto y Pedidos por WhatsApp</a:t>
             </a:r>
           </a:p>
           <a:p>
@@ -4074,7 +4074,7 @@
               </a:defRPr>
             </a:pPr>
             <a:r>
-              <a:t>Incuba un calendario de citas con franjas horarias y botón de confirmación.</a:t>
+              <a:t>Enlace directo para enviar consultas y reservas al móvil del comercio.</a:t>
             </a:r>
           </a:p>
           <a:p>
@@ -4087,7 +4087,7 @@
               </a:defRPr>
             </a:pPr>
             <a:r>
-              <a:t>💬 Dossier Comercial y Enlace WhatsApp</a:t>
+              <a:t>📱 Panel de Control Sencillo para el Dueño</a:t>
             </a:r>
           </a:p>
           <a:p>
@@ -4103,7 +4103,7 @@
               </a:defRPr>
             </a:pPr>
             <a:r>
-              <a:t>Genera informe PDF de auditoría y mensaje listo para enviar al dueño.</a:t>
+              <a:t>Gestión fácil de citas del día y cambios de horarios sin saber programar.</a:t>
             </a:r>
           </a:p>
         </p:txBody>
@@ -4158,7 +4158,7 @@
               </a:defRPr>
             </a:pPr>
             <a:r>
-              <a:t>🚀 Solución B2B SaaS • Arquitectura Modular y Aceleración con IA Generativa</a:t>
+              <a:t>🚀 Modelo B2B Micro-SaaS • Servicio Integral de Digitalización y Acompañamiento a Comercios</a:t>
             </a:r>
           </a:p>
         </p:txBody>
@@ -4377,7 +4377,7 @@
               </a:defRPr>
             </a:pPr>
             <a:r>
-              <a:t>3. Valor Diferencial y Mejoras Futuras</a:t>
+              <a:t>3. Valor Añadido del Servicio y Mejoras Futuras</a:t>
             </a:r>
           </a:p>
           <a:p>
@@ -4390,7 +4390,7 @@
               </a:defRPr>
             </a:pPr>
             <a:r>
-              <a:t>¿Por qué resulta útil esta solución y hacia dónde evoluciona?</a:t>
+              <a:t>¿Por qué resulta útil vender este servicio y cuál es su proyección futura?</a:t>
             </a:r>
           </a:p>
         </p:txBody>
@@ -4448,7 +4448,7 @@
               </a:defRPr>
             </a:pPr>
             <a:r>
-              <a:t>🌟 VALOR AÑADIDO (¿POR QUÉ ES ÚTIL?)</a:t>
+              <a:t>🌟 VALOR DEL SERVICIO (¿POR QUÉ ES ÚTIL?)</a:t>
             </a:r>
           </a:p>
           <a:p>
@@ -4461,7 +4461,7 @@
               </a:defRPr>
             </a:pPr>
             <a:r>
-              <a:t>✔ Demos Ya Construidas:</a:t>
+              <a:t>✔ Servicio 'Llave en Mano':</a:t>
             </a:r>
           </a:p>
           <a:p>
@@ -4477,7 +4477,7 @@
               </a:defRPr>
             </a:pPr>
             <a:r>
-              <a:t>   En lugar de promesas abstractas, el comercial llega con la web del negocio terminada para enseñar.</a:t>
+              <a:t>   El comerciante no compra un software suelto, sino un servicio activo que le lleva su tienda en Internet.</a:t>
             </a:r>
           </a:p>
           <a:p>
@@ -4490,7 +4490,7 @@
               </a:defRPr>
             </a:pPr>
             <a:r>
-              <a:t>✔ Ahorro de Semanas de Trabajo:</a:t>
+              <a:t>✔ Demostración Visual Instantánea:</a:t>
             </a:r>
           </a:p>
           <a:p>
@@ -4506,7 +4506,7 @@
               </a:defRPr>
             </a:pPr>
             <a:r>
-              <a:t>   Pasa de invertir 15 días en programar una web a generarla en 30 segundos con IA.</a:t>
+              <a:t>   El comercial se presenta con la tienda ya maquetada sobre datos de Google Maps, multiplicando el cierre de ventas.</a:t>
             </a:r>
           </a:p>
           <a:p>
@@ -4519,7 +4519,7 @@
               </a:defRPr>
             </a:pPr>
             <a:r>
-              <a:t>✔ Digitalización Real para la Pyme:</a:t>
+              <a:t>✔ Cuota Asequible por Suscripción:</a:t>
             </a:r>
           </a:p>
           <a:p>
@@ -4535,7 +4535,7 @@
               </a:defRPr>
             </a:pPr>
             <a:r>
-              <a:t>   El dueño del negocio obtiene web con citas por una fracción del precio habitual.</a:t>
+              <a:t>   Sustituye los presupuestos desorbitados de agencias por un servicio mensual accesible y mantenido.</a:t>
             </a:r>
           </a:p>
           <a:p>
@@ -4548,7 +4548,7 @@
               </a:defRPr>
             </a:pPr>
             <a:r>
-              <a:t>✔ Generación de Nuevos Negocios:</a:t>
+              <a:t>✔ Independencia para el Comerciante:</a:t>
             </a:r>
           </a:p>
           <a:p>
@@ -4564,7 +4564,7 @@
               </a:defRPr>
             </a:pPr>
             <a:r>
-              <a:t>   Crea oportunidades laborales para jóvenes titulados de DAM en servicios digitales.</a:t>
+              <a:t>   Panel intuitivo para consultar reservas sin depender de soporte técnico externo.</a:t>
             </a:r>
           </a:p>
         </p:txBody>
@@ -4635,7 +4635,7 @@
               </a:defRPr>
             </a:pPr>
             <a:r>
-              <a:t>✦ Bot de WhatsApp con IA:</a:t>
+              <a:t>✦ Bot de WhatsApp con IA 24/7:</a:t>
             </a:r>
           </a:p>
           <a:p>
@@ -4651,7 +4651,7 @@
               </a:defRPr>
             </a:pPr>
             <a:r>
-              <a:t>   Atención automatizada 24/7 para responder preguntas y confirmar reservas por chat.</a:t>
+              <a:t>   Atención automatizada para dudas frecuentes, confirmación de citas y recordatorios por chat.</a:t>
             </a:r>
           </a:p>
           <a:p>
@@ -4680,7 +4680,7 @@
               </a:defRPr>
             </a:pPr>
             <a:r>
-              <a:t>   Cobro de fianzas o citas online directamente en la web generada.</a:t>
+              <a:t>   Cobro de señales o venta directa de productos y servicios desde la propia web.</a:t>
             </a:r>
           </a:p>
           <a:p>
@@ -4693,7 +4693,7 @@
               </a:defRPr>
             </a:pPr>
             <a:r>
-              <a:t>✦ Despliegue Cloud en 1 Clic:</a:t>
+              <a:t>✦ Sincronización con Google Calendar:</a:t>
             </a:r>
           </a:p>
           <a:p>
@@ -4709,7 +4709,7 @@
               </a:defRPr>
             </a:pPr>
             <a:r>
-              <a:t>   Publicación automatizada del código en Vercel/Netlify con dominio personalizado.</a:t>
+              <a:t>   Conexión bidireccional automática con la agenda personal y de empleados del comercio.</a:t>
             </a:r>
           </a:p>
         </p:txBody>

</xml_diff>